<commit_message>
Add animations & transitions to Demo Video deck: slide fade/push/wipe transitions + staggered fade-in entrance for cards
</commit_message>
<xml_diff>
--- a/LIKA_Demo_Video.pptx
+++ b/LIKA_Demo_Video.pptx
@@ -3051,6 +3051,9 @@
       </p:sp>
     </p:spTree>
   </p:cSld>
+  <p:transition xmlns:p14="http://schemas.microsoft.com/office/powerpoint/2010/main" spd="med" p14:dur="600">
+    <p:fade/>
+  </p:transition>
   <p:clrMapOvr>
     <a:overrideClrMapping bg1="lt1" tx1="dk1" bg2="lt2" tx2="dk2" accent1="accent1" accent2="accent2" accent3="accent3" accent4="accent4" accent5="accent5" accent6="accent6" hlink="hlink" folHlink="folHlink"/>
   </p:clrMapOvr>
@@ -3578,6 +3581,221 @@
       </p:sp>
     </p:spTree>
   </p:cSld>
+  <p:transition xmlns:p14="http://schemas.microsoft.com/office/powerpoint/2010/main" spd="med" p14:dur="700">
+    <p:push dir="l"/>
+  </p:transition>
+  <p:timing>
+    <p:tnLst>
+      <p:par>
+        <p:cTn id="1" dur="indefinite" restart="never" nodeType="tmRoot">
+          <p:childTnLst>
+            <p:seq concurrent="1" nextAc="seek">
+              <p:cTn id="2" dur="indefinite" nodeType="mainSeq">
+                <p:childTnLst>
+                  <p:par>
+                    <p:cTn presetID="10" presetClass="entr" presetSubtype="0" fill="hold" grpId="0" nodeType="afterEffect">
+                      <p:stCondLst>
+                        <p:cond delay="0"/>
+                      </p:stCondLst>
+                      <p:childTnLst>
+                        <p:set>
+                          <p:cBhvr>
+                            <p:cTn dur="1" fill="hold">
+                              <p:stCondLst>
+                                <p:cond delay="0"/>
+                              </p:stCondLst>
+                            </p:cTn>
+                            <p:tgtEl>
+                              <p:spTgt spid="95"/>
+                            </p:tgtEl>
+                            <p:attrNameLst>
+                              <p:attrName>style.visibility</p:attrName>
+                            </p:attrNameLst>
+                          </p:cBhvr>
+                          <p:to>
+                            <p:strVal val="visible"/>
+                          </p:to>
+                        </p:set>
+                        <p:animEffect transition="in" filter="fade">
+                          <p:cBhvr>
+                            <p:cTn dur="500"/>
+                            <p:tgtEl>
+                              <p:spTgt spid="95"/>
+                            </p:tgtEl>
+                          </p:cBhvr>
+                        </p:animEffect>
+                      </p:childTnLst>
+                    </p:cTn>
+                  </p:par>
+                  <p:par>
+                    <p:cTn presetID="10" presetClass="entr" presetSubtype="0" fill="hold" grpId="0" nodeType="afterEffect">
+                      <p:stCondLst>
+                        <p:cond delay="300"/>
+                      </p:stCondLst>
+                      <p:childTnLst>
+                        <p:set>
+                          <p:cBhvr>
+                            <p:cTn dur="1" fill="hold">
+                              <p:stCondLst>
+                                <p:cond delay="0"/>
+                              </p:stCondLst>
+                            </p:cTn>
+                            <p:tgtEl>
+                              <p:spTgt spid="97"/>
+                            </p:tgtEl>
+                            <p:attrNameLst>
+                              <p:attrName>style.visibility</p:attrName>
+                            </p:attrNameLst>
+                          </p:cBhvr>
+                          <p:to>
+                            <p:strVal val="visible"/>
+                          </p:to>
+                        </p:set>
+                        <p:animEffect transition="in" filter="fade">
+                          <p:cBhvr>
+                            <p:cTn dur="500"/>
+                            <p:tgtEl>
+                              <p:spTgt spid="97"/>
+                            </p:tgtEl>
+                          </p:cBhvr>
+                        </p:animEffect>
+                      </p:childTnLst>
+                    </p:cTn>
+                  </p:par>
+                  <p:par>
+                    <p:cTn presetID="10" presetClass="entr" presetSubtype="0" fill="hold" grpId="0" nodeType="afterEffect">
+                      <p:stCondLst>
+                        <p:cond delay="300"/>
+                      </p:stCondLst>
+                      <p:childTnLst>
+                        <p:set>
+                          <p:cBhvr>
+                            <p:cTn dur="1" fill="hold">
+                              <p:stCondLst>
+                                <p:cond delay="0"/>
+                              </p:stCondLst>
+                            </p:cTn>
+                            <p:tgtEl>
+                              <p:spTgt spid="98"/>
+                            </p:tgtEl>
+                            <p:attrNameLst>
+                              <p:attrName>style.visibility</p:attrName>
+                            </p:attrNameLst>
+                          </p:cBhvr>
+                          <p:to>
+                            <p:strVal val="visible"/>
+                          </p:to>
+                        </p:set>
+                        <p:animEffect transition="in" filter="fade">
+                          <p:cBhvr>
+                            <p:cTn dur="500"/>
+                            <p:tgtEl>
+                              <p:spTgt spid="98"/>
+                            </p:tgtEl>
+                          </p:cBhvr>
+                        </p:animEffect>
+                      </p:childTnLst>
+                    </p:cTn>
+                  </p:par>
+                  <p:par>
+                    <p:cTn presetID="10" presetClass="entr" presetSubtype="0" fill="hold" grpId="0" nodeType="afterEffect">
+                      <p:stCondLst>
+                        <p:cond delay="300"/>
+                      </p:stCondLst>
+                      <p:childTnLst>
+                        <p:set>
+                          <p:cBhvr>
+                            <p:cTn dur="1" fill="hold">
+                              <p:stCondLst>
+                                <p:cond delay="0"/>
+                              </p:stCondLst>
+                            </p:cTn>
+                            <p:tgtEl>
+                              <p:spTgt spid="99"/>
+                            </p:tgtEl>
+                            <p:attrNameLst>
+                              <p:attrName>style.visibility</p:attrName>
+                            </p:attrNameLst>
+                          </p:cBhvr>
+                          <p:to>
+                            <p:strVal val="visible"/>
+                          </p:to>
+                        </p:set>
+                        <p:animEffect transition="in" filter="fade">
+                          <p:cBhvr>
+                            <p:cTn dur="500"/>
+                            <p:tgtEl>
+                              <p:spTgt spid="99"/>
+                            </p:tgtEl>
+                          </p:cBhvr>
+                        </p:animEffect>
+                      </p:childTnLst>
+                    </p:cTn>
+                  </p:par>
+                  <p:par>
+                    <p:cTn presetID="10" presetClass="entr" presetSubtype="0" fill="hold" grpId="0" nodeType="afterEffect">
+                      <p:stCondLst>
+                        <p:cond delay="300"/>
+                      </p:stCondLst>
+                      <p:childTnLst>
+                        <p:set>
+                          <p:cBhvr>
+                            <p:cTn dur="1" fill="hold">
+                              <p:stCondLst>
+                                <p:cond delay="0"/>
+                              </p:stCondLst>
+                            </p:cTn>
+                            <p:tgtEl>
+                              <p:spTgt spid="100"/>
+                            </p:tgtEl>
+                            <p:attrNameLst>
+                              <p:attrName>style.visibility</p:attrName>
+                            </p:attrNameLst>
+                          </p:cBhvr>
+                          <p:to>
+                            <p:strVal val="visible"/>
+                          </p:to>
+                        </p:set>
+                        <p:animEffect transition="in" filter="fade">
+                          <p:cBhvr>
+                            <p:cTn dur="500"/>
+                            <p:tgtEl>
+                              <p:spTgt spid="100"/>
+                            </p:tgtEl>
+                          </p:cBhvr>
+                        </p:animEffect>
+                      </p:childTnLst>
+                    </p:cTn>
+                  </p:par>
+                </p:childTnLst>
+              </p:cTn>
+              <p:prevCondLst>
+                <p:cond evt="onPrev" delay="0">
+                  <p:tgtEl>
+                    <p:sldTgt/>
+                  </p:tgtEl>
+                </p:cond>
+              </p:prevCondLst>
+              <p:nextCondLst>
+                <p:cond evt="onNext" delay="0">
+                  <p:tgtEl>
+                    <p:sldTgt/>
+                  </p:tgtEl>
+                </p:cond>
+              </p:nextCondLst>
+            </p:seq>
+          </p:childTnLst>
+        </p:cTn>
+      </p:par>
+    </p:tnLst>
+    <p:bldLst>
+      <p:bldP spid="95" grpId="0"/>
+      <p:bldP spid="97" grpId="0"/>
+      <p:bldP spid="98" grpId="0"/>
+      <p:bldP spid="99" grpId="0"/>
+      <p:bldP spid="100" grpId="0"/>
+    </p:bldLst>
+  </p:timing>
   <p:clrMapOvr>
     <a:overrideClrMapping bg1="lt1" tx1="dk1" bg2="lt2" tx2="dk2" accent1="accent1" accent2="accent2" accent3="accent3" accent4="accent4" accent5="accent5" accent6="accent6" hlink="hlink" folHlink="folHlink"/>
   </p:clrMapOvr>
@@ -4577,6 +4795,185 @@
       </p:sp>
     </p:spTree>
   </p:cSld>
+  <p:transition xmlns:p14="http://schemas.microsoft.com/office/powerpoint/2010/main" spd="med" p14:dur="600">
+    <p:fade/>
+  </p:transition>
+  <p:timing>
+    <p:tnLst>
+      <p:par>
+        <p:cTn id="1" dur="indefinite" restart="never" nodeType="tmRoot">
+          <p:childTnLst>
+            <p:seq concurrent="1" nextAc="seek">
+              <p:cTn id="2" dur="indefinite" nodeType="mainSeq">
+                <p:childTnLst>
+                  <p:par>
+                    <p:cTn presetID="10" presetClass="entr" presetSubtype="0" fill="hold" grpId="0" nodeType="afterEffect">
+                      <p:stCondLst>
+                        <p:cond delay="0"/>
+                      </p:stCondLst>
+                      <p:childTnLst>
+                        <p:set>
+                          <p:cBhvr>
+                            <p:cTn dur="1" fill="hold">
+                              <p:stCondLst>
+                                <p:cond delay="0"/>
+                              </p:stCondLst>
+                            </p:cTn>
+                            <p:tgtEl>
+                              <p:spTgt spid="108"/>
+                            </p:tgtEl>
+                            <p:attrNameLst>
+                              <p:attrName>style.visibility</p:attrName>
+                            </p:attrNameLst>
+                          </p:cBhvr>
+                          <p:to>
+                            <p:strVal val="visible"/>
+                          </p:to>
+                        </p:set>
+                        <p:animEffect transition="in" filter="fade">
+                          <p:cBhvr>
+                            <p:cTn dur="500"/>
+                            <p:tgtEl>
+                              <p:spTgt spid="108"/>
+                            </p:tgtEl>
+                          </p:cBhvr>
+                        </p:animEffect>
+                      </p:childTnLst>
+                    </p:cTn>
+                  </p:par>
+                  <p:par>
+                    <p:cTn presetID="10" presetClass="entr" presetSubtype="0" fill="hold" grpId="0" nodeType="afterEffect">
+                      <p:stCondLst>
+                        <p:cond delay="300"/>
+                      </p:stCondLst>
+                      <p:childTnLst>
+                        <p:set>
+                          <p:cBhvr>
+                            <p:cTn dur="1" fill="hold">
+                              <p:stCondLst>
+                                <p:cond delay="0"/>
+                              </p:stCondLst>
+                            </p:cTn>
+                            <p:tgtEl>
+                              <p:spTgt spid="113"/>
+                            </p:tgtEl>
+                            <p:attrNameLst>
+                              <p:attrName>style.visibility</p:attrName>
+                            </p:attrNameLst>
+                          </p:cBhvr>
+                          <p:to>
+                            <p:strVal val="visible"/>
+                          </p:to>
+                        </p:set>
+                        <p:animEffect transition="in" filter="fade">
+                          <p:cBhvr>
+                            <p:cTn dur="500"/>
+                            <p:tgtEl>
+                              <p:spTgt spid="113"/>
+                            </p:tgtEl>
+                          </p:cBhvr>
+                        </p:animEffect>
+                      </p:childTnLst>
+                    </p:cTn>
+                  </p:par>
+                  <p:par>
+                    <p:cTn presetID="10" presetClass="entr" presetSubtype="0" fill="hold" grpId="0" nodeType="afterEffect">
+                      <p:stCondLst>
+                        <p:cond delay="300"/>
+                      </p:stCondLst>
+                      <p:childTnLst>
+                        <p:set>
+                          <p:cBhvr>
+                            <p:cTn dur="1" fill="hold">
+                              <p:stCondLst>
+                                <p:cond delay="0"/>
+                              </p:stCondLst>
+                            </p:cTn>
+                            <p:tgtEl>
+                              <p:spTgt spid="118"/>
+                            </p:tgtEl>
+                            <p:attrNameLst>
+                              <p:attrName>style.visibility</p:attrName>
+                            </p:attrNameLst>
+                          </p:cBhvr>
+                          <p:to>
+                            <p:strVal val="visible"/>
+                          </p:to>
+                        </p:set>
+                        <p:animEffect transition="in" filter="fade">
+                          <p:cBhvr>
+                            <p:cTn dur="500"/>
+                            <p:tgtEl>
+                              <p:spTgt spid="118"/>
+                            </p:tgtEl>
+                          </p:cBhvr>
+                        </p:animEffect>
+                      </p:childTnLst>
+                    </p:cTn>
+                  </p:par>
+                  <p:par>
+                    <p:cTn presetID="10" presetClass="entr" presetSubtype="0" fill="hold" grpId="0" nodeType="afterEffect">
+                      <p:stCondLst>
+                        <p:cond delay="300"/>
+                      </p:stCondLst>
+                      <p:childTnLst>
+                        <p:set>
+                          <p:cBhvr>
+                            <p:cTn dur="1" fill="hold">
+                              <p:stCondLst>
+                                <p:cond delay="0"/>
+                              </p:stCondLst>
+                            </p:cTn>
+                            <p:tgtEl>
+                              <p:spTgt spid="123"/>
+                            </p:tgtEl>
+                            <p:attrNameLst>
+                              <p:attrName>style.visibility</p:attrName>
+                            </p:attrNameLst>
+                          </p:cBhvr>
+                          <p:to>
+                            <p:strVal val="visible"/>
+                          </p:to>
+                        </p:set>
+                        <p:animEffect transition="in" filter="fade">
+                          <p:cBhvr>
+                            <p:cTn dur="500"/>
+                            <p:tgtEl>
+                              <p:spTgt spid="123"/>
+                            </p:tgtEl>
+                          </p:cBhvr>
+                        </p:animEffect>
+                      </p:childTnLst>
+                    </p:cTn>
+                  </p:par>
+                </p:childTnLst>
+              </p:cTn>
+              <p:prevCondLst>
+                <p:cond evt="onPrev" delay="0">
+                  <p:tgtEl>
+                    <p:sldTgt/>
+                  </p:tgtEl>
+                </p:cond>
+              </p:prevCondLst>
+              <p:nextCondLst>
+                <p:cond evt="onNext" delay="0">
+                  <p:tgtEl>
+                    <p:sldTgt/>
+                  </p:tgtEl>
+                </p:cond>
+              </p:nextCondLst>
+            </p:seq>
+          </p:childTnLst>
+        </p:cTn>
+      </p:par>
+    </p:tnLst>
+    <p:bldLst>
+      <p:bldP spid="108" grpId="0"/>
+      <p:bldP spid="113" grpId="0"/>
+      <p:bldP spid="118" grpId="0"/>
+      <p:bldP spid="123" grpId="0"/>
+    </p:bldLst>
+  </p:timing>
   <p:clrMapOvr>
     <a:overrideClrMapping bg1="lt1" tx1="dk1" bg2="lt2" tx2="dk2" accent1="accent1" accent2="accent2" accent3="accent3" accent4="accent4" accent5="accent5" accent6="accent6" hlink="hlink" folHlink="folHlink"/>
   </p:clrMapOvr>
@@ -5416,6 +5813,113 @@
       </p:sp>
     </p:spTree>
   </p:cSld>
+  <p:transition xmlns:p14="http://schemas.microsoft.com/office/powerpoint/2010/main" spd="med" p14:dur="700">
+    <p:wipe dir="l"/>
+  </p:transition>
+  <p:timing>
+    <p:tnLst>
+      <p:par>
+        <p:cTn id="1" dur="indefinite" restart="never" nodeType="tmRoot">
+          <p:childTnLst>
+            <p:seq concurrent="1" nextAc="seek">
+              <p:cTn id="2" dur="indefinite" nodeType="mainSeq">
+                <p:childTnLst>
+                  <p:par>
+                    <p:cTn presetID="10" presetClass="entr" presetSubtype="0" fill="hold" grpId="0" nodeType="afterEffect">
+                      <p:stCondLst>
+                        <p:cond delay="0"/>
+                      </p:stCondLst>
+                      <p:childTnLst>
+                        <p:set>
+                          <p:cBhvr>
+                            <p:cTn dur="1" fill="hold">
+                              <p:stCondLst>
+                                <p:cond delay="0"/>
+                              </p:stCondLst>
+                            </p:cTn>
+                            <p:tgtEl>
+                              <p:spTgt spid="135"/>
+                            </p:tgtEl>
+                            <p:attrNameLst>
+                              <p:attrName>style.visibility</p:attrName>
+                            </p:attrNameLst>
+                          </p:cBhvr>
+                          <p:to>
+                            <p:strVal val="visible"/>
+                          </p:to>
+                        </p:set>
+                        <p:animEffect transition="in" filter="fade">
+                          <p:cBhvr>
+                            <p:cTn dur="500"/>
+                            <p:tgtEl>
+                              <p:spTgt spid="135"/>
+                            </p:tgtEl>
+                          </p:cBhvr>
+                        </p:animEffect>
+                      </p:childTnLst>
+                    </p:cTn>
+                  </p:par>
+                  <p:par>
+                    <p:cTn presetID="10" presetClass="entr" presetSubtype="0" fill="hold" grpId="0" nodeType="afterEffect">
+                      <p:stCondLst>
+                        <p:cond delay="300"/>
+                      </p:stCondLst>
+                      <p:childTnLst>
+                        <p:set>
+                          <p:cBhvr>
+                            <p:cTn dur="1" fill="hold">
+                              <p:stCondLst>
+                                <p:cond delay="0"/>
+                              </p:stCondLst>
+                            </p:cTn>
+                            <p:tgtEl>
+                              <p:spTgt spid="142"/>
+                            </p:tgtEl>
+                            <p:attrNameLst>
+                              <p:attrName>style.visibility</p:attrName>
+                            </p:attrNameLst>
+                          </p:cBhvr>
+                          <p:to>
+                            <p:strVal val="visible"/>
+                          </p:to>
+                        </p:set>
+                        <p:animEffect transition="in" filter="fade">
+                          <p:cBhvr>
+                            <p:cTn dur="500"/>
+                            <p:tgtEl>
+                              <p:spTgt spid="142"/>
+                            </p:tgtEl>
+                          </p:cBhvr>
+                        </p:animEffect>
+                      </p:childTnLst>
+                    </p:cTn>
+                  </p:par>
+                </p:childTnLst>
+              </p:cTn>
+              <p:prevCondLst>
+                <p:cond evt="onPrev" delay="0">
+                  <p:tgtEl>
+                    <p:sldTgt/>
+                  </p:tgtEl>
+                </p:cond>
+              </p:prevCondLst>
+              <p:nextCondLst>
+                <p:cond evt="onNext" delay="0">
+                  <p:tgtEl>
+                    <p:sldTgt/>
+                  </p:tgtEl>
+                </p:cond>
+              </p:nextCondLst>
+            </p:seq>
+          </p:childTnLst>
+        </p:cTn>
+      </p:par>
+    </p:tnLst>
+    <p:bldLst>
+      <p:bldP spid="135" grpId="0"/>
+      <p:bldP spid="142" grpId="0"/>
+    </p:bldLst>
+  </p:timing>
   <p:clrMapOvr>
     <a:overrideClrMapping bg1="lt1" tx1="dk1" bg2="lt2" tx2="dk2" accent1="accent1" accent2="accent2" accent3="accent3" accent4="accent4" accent5="accent5" accent6="accent6" hlink="hlink" folHlink="folHlink"/>
   </p:clrMapOvr>
@@ -6517,6 +7021,9 @@
       </p:sp>
     </p:spTree>
   </p:cSld>
+  <p:transition xmlns:p14="http://schemas.microsoft.com/office/powerpoint/2010/main" spd="med" p14:dur="600">
+    <p:fade/>
+  </p:transition>
   <p:clrMapOvr>
     <a:overrideClrMapping bg1="lt1" tx1="dk1" bg2="lt2" tx2="dk2" accent1="accent1" accent2="accent2" accent3="accent3" accent4="accent4" accent5="accent5" accent6="accent6" hlink="hlink" folHlink="folHlink"/>
   </p:clrMapOvr>
@@ -7228,6 +7735,185 @@
       </p:sp>
     </p:spTree>
   </p:cSld>
+  <p:transition xmlns:p14="http://schemas.microsoft.com/office/powerpoint/2010/main" spd="med" p14:dur="700">
+    <p:push dir="l"/>
+  </p:transition>
+  <p:timing>
+    <p:tnLst>
+      <p:par>
+        <p:cTn id="1" dur="indefinite" restart="never" nodeType="tmRoot">
+          <p:childTnLst>
+            <p:seq concurrent="1" nextAc="seek">
+              <p:cTn id="2" dur="indefinite" nodeType="mainSeq">
+                <p:childTnLst>
+                  <p:par>
+                    <p:cTn presetID="10" presetClass="entr" presetSubtype="0" fill="hold" grpId="0" nodeType="afterEffect">
+                      <p:stCondLst>
+                        <p:cond delay="0"/>
+                      </p:stCondLst>
+                      <p:childTnLst>
+                        <p:set>
+                          <p:cBhvr>
+                            <p:cTn dur="1" fill="hold">
+                              <p:stCondLst>
+                                <p:cond delay="0"/>
+                              </p:stCondLst>
+                            </p:cTn>
+                            <p:tgtEl>
+                              <p:spTgt spid="187"/>
+                            </p:tgtEl>
+                            <p:attrNameLst>
+                              <p:attrName>style.visibility</p:attrName>
+                            </p:attrNameLst>
+                          </p:cBhvr>
+                          <p:to>
+                            <p:strVal val="visible"/>
+                          </p:to>
+                        </p:set>
+                        <p:animEffect transition="in" filter="fade">
+                          <p:cBhvr>
+                            <p:cTn dur="500"/>
+                            <p:tgtEl>
+                              <p:spTgt spid="187"/>
+                            </p:tgtEl>
+                          </p:cBhvr>
+                        </p:animEffect>
+                      </p:childTnLst>
+                    </p:cTn>
+                  </p:par>
+                  <p:par>
+                    <p:cTn presetID="10" presetClass="entr" presetSubtype="0" fill="hold" grpId="0" nodeType="afterEffect">
+                      <p:stCondLst>
+                        <p:cond delay="300"/>
+                      </p:stCondLst>
+                      <p:childTnLst>
+                        <p:set>
+                          <p:cBhvr>
+                            <p:cTn dur="1" fill="hold">
+                              <p:stCondLst>
+                                <p:cond delay="0"/>
+                              </p:stCondLst>
+                            </p:cTn>
+                            <p:tgtEl>
+                              <p:spTgt spid="190"/>
+                            </p:tgtEl>
+                            <p:attrNameLst>
+                              <p:attrName>style.visibility</p:attrName>
+                            </p:attrNameLst>
+                          </p:cBhvr>
+                          <p:to>
+                            <p:strVal val="visible"/>
+                          </p:to>
+                        </p:set>
+                        <p:animEffect transition="in" filter="fade">
+                          <p:cBhvr>
+                            <p:cTn dur="500"/>
+                            <p:tgtEl>
+                              <p:spTgt spid="190"/>
+                            </p:tgtEl>
+                          </p:cBhvr>
+                        </p:animEffect>
+                      </p:childTnLst>
+                    </p:cTn>
+                  </p:par>
+                  <p:par>
+                    <p:cTn presetID="10" presetClass="entr" presetSubtype="0" fill="hold" grpId="0" nodeType="afterEffect">
+                      <p:stCondLst>
+                        <p:cond delay="300"/>
+                      </p:stCondLst>
+                      <p:childTnLst>
+                        <p:set>
+                          <p:cBhvr>
+                            <p:cTn dur="1" fill="hold">
+                              <p:stCondLst>
+                                <p:cond delay="0"/>
+                              </p:stCondLst>
+                            </p:cTn>
+                            <p:tgtEl>
+                              <p:spTgt spid="193"/>
+                            </p:tgtEl>
+                            <p:attrNameLst>
+                              <p:attrName>style.visibility</p:attrName>
+                            </p:attrNameLst>
+                          </p:cBhvr>
+                          <p:to>
+                            <p:strVal val="visible"/>
+                          </p:to>
+                        </p:set>
+                        <p:animEffect transition="in" filter="fade">
+                          <p:cBhvr>
+                            <p:cTn dur="500"/>
+                            <p:tgtEl>
+                              <p:spTgt spid="193"/>
+                            </p:tgtEl>
+                          </p:cBhvr>
+                        </p:animEffect>
+                      </p:childTnLst>
+                    </p:cTn>
+                  </p:par>
+                  <p:par>
+                    <p:cTn presetID="10" presetClass="entr" presetSubtype="0" fill="hold" grpId="0" nodeType="afterEffect">
+                      <p:stCondLst>
+                        <p:cond delay="300"/>
+                      </p:stCondLst>
+                      <p:childTnLst>
+                        <p:set>
+                          <p:cBhvr>
+                            <p:cTn dur="1" fill="hold">
+                              <p:stCondLst>
+                                <p:cond delay="0"/>
+                              </p:stCondLst>
+                            </p:cTn>
+                            <p:tgtEl>
+                              <p:spTgt spid="196"/>
+                            </p:tgtEl>
+                            <p:attrNameLst>
+                              <p:attrName>style.visibility</p:attrName>
+                            </p:attrNameLst>
+                          </p:cBhvr>
+                          <p:to>
+                            <p:strVal val="visible"/>
+                          </p:to>
+                        </p:set>
+                        <p:animEffect transition="in" filter="fade">
+                          <p:cBhvr>
+                            <p:cTn dur="500"/>
+                            <p:tgtEl>
+                              <p:spTgt spid="196"/>
+                            </p:tgtEl>
+                          </p:cBhvr>
+                        </p:animEffect>
+                      </p:childTnLst>
+                    </p:cTn>
+                  </p:par>
+                </p:childTnLst>
+              </p:cTn>
+              <p:prevCondLst>
+                <p:cond evt="onPrev" delay="0">
+                  <p:tgtEl>
+                    <p:sldTgt/>
+                  </p:tgtEl>
+                </p:cond>
+              </p:prevCondLst>
+              <p:nextCondLst>
+                <p:cond evt="onNext" delay="0">
+                  <p:tgtEl>
+                    <p:sldTgt/>
+                  </p:tgtEl>
+                </p:cond>
+              </p:nextCondLst>
+            </p:seq>
+          </p:childTnLst>
+        </p:cTn>
+      </p:par>
+    </p:tnLst>
+    <p:bldLst>
+      <p:bldP spid="187" grpId="0"/>
+      <p:bldP spid="190" grpId="0"/>
+      <p:bldP spid="193" grpId="0"/>
+      <p:bldP spid="196" grpId="0"/>
+    </p:bldLst>
+  </p:timing>
   <p:clrMapOvr>
     <a:overrideClrMapping bg1="lt1" tx1="dk1" bg2="lt2" tx2="dk2" accent1="accent1" accent2="accent2" accent3="accent3" accent4="accent4" accent5="accent5" accent6="accent6" hlink="hlink" folHlink="folHlink"/>
   </p:clrMapOvr>
@@ -8771,6 +9457,9 @@
       </p:sp>
     </p:spTree>
   </p:cSld>
+  <p:transition xmlns:p14="http://schemas.microsoft.com/office/powerpoint/2010/main" spd="med" p14:dur="600">
+    <p:fade/>
+  </p:transition>
   <p:clrMapOvr>
     <a:overrideClrMapping bg1="lt1" tx1="dk1" bg2="lt2" tx2="dk2" accent1="accent1" accent2="accent2" accent3="accent3" accent4="accent4" accent5="accent5" accent6="accent6" hlink="hlink" folHlink="folHlink"/>
   </p:clrMapOvr>

</xml_diff>